<commit_message>
Update 이어말하기 assets and add ZIP slides
Co-Authored-By: Claude Opus 4.6 (1M context) <noreply@anthropic.com>
</commit_message>
<xml_diff>
--- a/public/downloads/games/word-relay/rules.pptx
+++ b/public/downloads/games/word-relay/rules.pptx
@@ -15,16 +15,12 @@
   <p:notesSz cx="6858000" cy="9144000"/>
   <p:embeddedFontLst>
     <p:embeddedFont>
-      <p:font typeface="Jua" charset="1" panose="00000000000000000000"/>
+      <p:font typeface="무궁화 고딕" charset="1" panose="02020603020101020101"/>
       <p:regular r:id="rId11"/>
     </p:embeddedFont>
     <p:embeddedFont>
-      <p:font typeface="TDTD갬성명조" charset="1" panose="02000503000000000000"/>
+      <p:font typeface="무궁화 고딕 Bold" charset="1" panose="02020603020101020101"/>
       <p:regular r:id="rId12"/>
-    </p:embeddedFont>
-    <p:embeddedFont>
-      <p:font typeface="TDTD가온" charset="1" panose="02000503000000000000"/>
-      <p:regular r:id="rId13"/>
     </p:embeddedFont>
   </p:embeddedFontLst>
   <p:defaultTextStyle>
@@ -3142,8 +3138,8 @@
         </p:nvSpPr>
         <p:spPr>
           <a:xfrm rot="0">
-            <a:off x="1028700" y="3892867"/>
-            <a:ext cx="15555091" cy="2200275"/>
+            <a:off x="1028700" y="4178617"/>
+            <a:ext cx="15555091" cy="1914525"/>
           </a:xfrm>
           <a:prstGeom prst="rect">
             <a:avLst/>
@@ -3165,10 +3161,10 @@
                 <a:solidFill>
                   <a:srgbClr val="FFFAEF"/>
                 </a:solidFill>
-                <a:latin typeface="Jua"/>
-                <a:ea typeface="Jua"/>
-                <a:cs typeface="Jua"/>
-                <a:sym typeface="Jua"/>
+                <a:latin typeface="무궁화 고딕"/>
+                <a:ea typeface="무궁화 고딕"/>
+                <a:cs typeface="무궁화 고딕"/>
+                <a:sym typeface="무궁화 고딕"/>
               </a:rPr>
               <a:t>이어말하기</a:t>
             </a:r>
@@ -3183,8 +3179,8 @@
         </p:nvSpPr>
         <p:spPr>
           <a:xfrm rot="0">
-            <a:off x="15264803" y="9812655"/>
-            <a:ext cx="2637975" cy="474345"/>
+            <a:off x="13460066" y="9822180"/>
+            <a:ext cx="4442712" cy="464820"/>
           </a:xfrm>
           <a:prstGeom prst="rect">
             <a:avLst/>
@@ -3209,10 +3205,10 @@
                 <a:solidFill>
                   <a:srgbClr val="FFFFFF"/>
                 </a:solidFill>
-                <a:latin typeface="TDTD갬성명조"/>
-                <a:ea typeface="TDTD갬성명조"/>
-                <a:cs typeface="TDTD갬성명조"/>
-                <a:sym typeface="TDTD갬성명조"/>
+                <a:latin typeface="무궁화 고딕"/>
+                <a:ea typeface="무궁화 고딕"/>
+                <a:cs typeface="무궁화 고딕"/>
+                <a:sym typeface="무궁화 고딕"/>
               </a:rPr>
               <a:t>ⓒ 2026. Sunday Play</a:t>
             </a:r>
@@ -3361,8 +3357,8 @@
         </p:nvSpPr>
         <p:spPr>
           <a:xfrm rot="0">
-            <a:off x="11392761" y="600705"/>
-            <a:ext cx="5362043" cy="1600200"/>
+            <a:off x="11392761" y="819780"/>
+            <a:ext cx="5362043" cy="1381125"/>
           </a:xfrm>
           <a:prstGeom prst="rect">
             <a:avLst/>
@@ -3384,10 +3380,10 @@
                 <a:solidFill>
                   <a:srgbClr val="FFFAEF"/>
                 </a:solidFill>
-                <a:latin typeface="Jua"/>
-                <a:ea typeface="Jua"/>
-                <a:cs typeface="Jua"/>
-                <a:sym typeface="Jua"/>
+                <a:latin typeface="무궁화 고딕"/>
+                <a:ea typeface="무궁화 고딕"/>
+                <a:cs typeface="무궁화 고딕"/>
+                <a:sym typeface="무궁화 고딕"/>
               </a:rPr>
               <a:t>규칙</a:t>
             </a:r>
@@ -3403,9 +3399,9 @@
         <p:grpSpPr>
           <a:xfrm rot="0">
             <a:off x="309172" y="535073"/>
-            <a:ext cx="11933749" cy="2836235"/>
+            <a:ext cx="11933749" cy="1877384"/>
             <a:chOff x="0" y="0"/>
-            <a:chExt cx="15911666" cy="3781647"/>
+            <a:chExt cx="15911666" cy="2503179"/>
           </a:xfrm>
         </p:grpSpPr>
         <p:sp>
@@ -3417,7 +3413,7 @@
           <p:spPr>
             <a:xfrm rot="0">
               <a:off x="0" y="1493529"/>
-              <a:ext cx="15911666" cy="2288118"/>
+              <a:ext cx="15911666" cy="1009650"/>
             </a:xfrm>
             <a:prstGeom prst="rect">
               <a:avLst/>
@@ -3431,28 +3427,21 @@
             <a:p>
               <a:pPr algn="l">
                 <a:lnSpc>
-                  <a:spcPts val="6999"/>
+                  <a:spcPts val="6299"/>
                 </a:lnSpc>
               </a:pPr>
               <a:r>
-                <a:rPr lang="en-US" sz="4999">
+                <a:rPr lang="en-US" sz="4500">
                   <a:solidFill>
                     <a:srgbClr val="FFFAEF"/>
                   </a:solidFill>
-                  <a:latin typeface="TDTD가온"/>
-                  <a:ea typeface="TDTD가온"/>
-                  <a:cs typeface="TDTD가온"/>
-                  <a:sym typeface="TDTD가온"/>
+                  <a:latin typeface="무궁화 고딕"/>
+                  <a:ea typeface="무궁화 고딕"/>
+                  <a:cs typeface="무궁화 고딕"/>
+                  <a:sym typeface="무궁화 고딕"/>
                 </a:rPr>
                 <a:t>네 글자 단어의 앞 두 글자만 말합니다.</a:t>
               </a:r>
-            </a:p>
-            <a:p>
-              <a:pPr algn="l">
-                <a:lnSpc>
-                  <a:spcPts val="6999"/>
-                </a:lnSpc>
-              </a:pPr>
             </a:p>
           </p:txBody>
         </p:sp>
@@ -3464,8 +3453,8 @@
           </p:nvSpPr>
           <p:spPr>
             <a:xfrm rot="0">
-              <a:off x="0" y="-171450"/>
-              <a:ext cx="10684245" cy="1237404"/>
+              <a:off x="0" y="-57150"/>
+              <a:ext cx="10684245" cy="1123104"/>
             </a:xfrm>
             <a:prstGeom prst="rect">
               <a:avLst/>
@@ -3487,10 +3476,10 @@
                   <a:solidFill>
                     <a:srgbClr val="FFFAEF"/>
                   </a:solidFill>
-                  <a:latin typeface="Jua"/>
-                  <a:ea typeface="Jua"/>
-                  <a:cs typeface="Jua"/>
-                  <a:sym typeface="Jua"/>
+                  <a:latin typeface="무궁화 고딕 Bold"/>
+                  <a:ea typeface="무궁화 고딕 Bold"/>
+                  <a:cs typeface="무궁화 고딕 Bold"/>
+                  <a:sym typeface="무궁화 고딕 Bold"/>
                 </a:rPr>
                 <a:t>STEP 1.</a:t>
               </a:r>
@@ -3506,10 +3495,10 @@
         </p:nvGrpSpPr>
         <p:grpSpPr>
           <a:xfrm rot="0">
-            <a:off x="10031477" y="7721059"/>
-            <a:ext cx="8256523" cy="2831372"/>
+            <a:off x="10031477" y="8061954"/>
+            <a:ext cx="8256523" cy="1862996"/>
             <a:chOff x="0" y="0"/>
-            <a:chExt cx="11008697" cy="3775162"/>
+            <a:chExt cx="11008697" cy="2483995"/>
           </a:xfrm>
         </p:grpSpPr>
         <p:sp>
@@ -3520,8 +3509,8 @@
           </p:nvSpPr>
           <p:spPr>
             <a:xfrm rot="0">
-              <a:off x="0" y="1487044"/>
-              <a:ext cx="11008697" cy="2288119"/>
+              <a:off x="0" y="1496569"/>
+              <a:ext cx="11008697" cy="987427"/>
             </a:xfrm>
             <a:prstGeom prst="rect">
               <a:avLst/>
@@ -3535,40 +3524,33 @@
             <a:p>
               <a:pPr algn="l">
                 <a:lnSpc>
-                  <a:spcPts val="6999"/>
+                  <a:spcPts val="6299"/>
                 </a:lnSpc>
               </a:pPr>
               <a:r>
-                <a:rPr lang="en-US" sz="4999">
+                <a:rPr lang="en-US" sz="4499">
                   <a:solidFill>
                     <a:srgbClr val="FFFAEF"/>
                   </a:solidFill>
-                  <a:latin typeface="TDTD가온"/>
-                  <a:ea typeface="TDTD가온"/>
-                  <a:cs typeface="TDTD가온"/>
-                  <a:sym typeface="TDTD가온"/>
+                  <a:latin typeface="무궁화 고딕"/>
+                  <a:ea typeface="무궁화 고딕"/>
+                  <a:cs typeface="무궁화 고딕"/>
+                  <a:sym typeface="무궁화 고딕"/>
                 </a:rPr>
                 <a:t>가장</a:t>
               </a:r>
               <a:r>
-                <a:rPr lang="en-US" sz="4999">
+                <a:rPr lang="en-US" sz="4499">
                   <a:solidFill>
                     <a:srgbClr val="FFFAEF"/>
                   </a:solidFill>
-                  <a:latin typeface="TDTD가온"/>
-                  <a:ea typeface="TDTD가온"/>
-                  <a:cs typeface="TDTD가온"/>
-                  <a:sym typeface="TDTD가온"/>
+                  <a:latin typeface="무궁화 고딕"/>
+                  <a:ea typeface="무궁화 고딕"/>
+                  <a:cs typeface="무궁화 고딕"/>
+                  <a:sym typeface="무궁화 고딕"/>
                 </a:rPr>
                 <a:t> 많은 문제를 맞춘 팀이 우승!</a:t>
               </a:r>
-            </a:p>
-            <a:p>
-              <a:pPr algn="l">
-                <a:lnSpc>
-                  <a:spcPts val="6999"/>
-                </a:lnSpc>
-              </a:pPr>
             </a:p>
           </p:txBody>
         </p:sp>
@@ -3580,8 +3562,8 @@
           </p:nvSpPr>
           <p:spPr>
             <a:xfrm rot="0">
-              <a:off x="0" y="-171450"/>
-              <a:ext cx="11008697" cy="1237404"/>
+              <a:off x="0" y="-57150"/>
+              <a:ext cx="11008697" cy="1123104"/>
             </a:xfrm>
             <a:prstGeom prst="rect">
               <a:avLst/>
@@ -3603,10 +3585,10 @@
                   <a:solidFill>
                     <a:srgbClr val="FFFAEF"/>
                   </a:solidFill>
-                  <a:latin typeface="Jua"/>
-                  <a:ea typeface="Jua"/>
-                  <a:cs typeface="Jua"/>
-                  <a:sym typeface="Jua"/>
+                  <a:latin typeface="무궁화 고딕 Bold"/>
+                  <a:ea typeface="무궁화 고딕 Bold"/>
+                  <a:cs typeface="무궁화 고딕 Bold"/>
+                  <a:sym typeface="무궁화 고딕 Bold"/>
                 </a:rPr>
                 <a:t>STEP 3.</a:t>
               </a:r>
@@ -3622,10 +3604,10 @@
         </p:nvGrpSpPr>
         <p:grpSpPr>
           <a:xfrm rot="0">
-            <a:off x="4621704" y="3284902"/>
-            <a:ext cx="8281233" cy="3717196"/>
+            <a:off x="4621704" y="3500845"/>
+            <a:ext cx="8561970" cy="3472720"/>
             <a:chOff x="0" y="0"/>
-            <a:chExt cx="11041644" cy="4956262"/>
+            <a:chExt cx="11415960" cy="4630293"/>
           </a:xfrm>
         </p:grpSpPr>
         <p:sp>
@@ -3637,7 +3619,7 @@
           <p:spPr>
             <a:xfrm rot="0">
               <a:off x="0" y="1487043"/>
-              <a:ext cx="11041644" cy="3469219"/>
+              <a:ext cx="11415960" cy="3143250"/>
             </a:xfrm>
             <a:prstGeom prst="rect">
               <a:avLst/>
@@ -3651,18 +3633,18 @@
             <a:p>
               <a:pPr algn="l">
                 <a:lnSpc>
-                  <a:spcPts val="6999"/>
+                  <a:spcPts val="6299"/>
                 </a:lnSpc>
               </a:pPr>
               <a:r>
-                <a:rPr lang="en-US" sz="4999">
+                <a:rPr lang="en-US" sz="4500">
                   <a:solidFill>
                     <a:srgbClr val="FFFAEF"/>
                   </a:solidFill>
-                  <a:latin typeface="TDTD가온"/>
-                  <a:ea typeface="TDTD가온"/>
-                  <a:cs typeface="TDTD가온"/>
-                  <a:sym typeface="TDTD가온"/>
+                  <a:latin typeface="무궁화 고딕"/>
+                  <a:ea typeface="무궁화 고딕"/>
+                  <a:cs typeface="무궁화 고딕"/>
+                  <a:sym typeface="무궁화 고딕"/>
                 </a:rPr>
                 <a:t>한 팀씩 도전!</a:t>
               </a:r>
@@ -3670,30 +3652,30 @@
             <a:p>
               <a:pPr algn="l">
                 <a:lnSpc>
-                  <a:spcPts val="6999"/>
+                  <a:spcPts val="6299"/>
                 </a:lnSpc>
               </a:pPr>
               <a:r>
-                <a:rPr lang="en-US" sz="4999">
+                <a:rPr lang="en-US" sz="4500">
                   <a:solidFill>
                     <a:srgbClr val="FFFAEF"/>
                   </a:solidFill>
-                  <a:latin typeface="TDTD가온"/>
-                  <a:ea typeface="TDTD가온"/>
-                  <a:cs typeface="TDTD가온"/>
-                  <a:sym typeface="TDTD가온"/>
+                  <a:latin typeface="무궁화 고딕"/>
+                  <a:ea typeface="무궁화 고딕"/>
+                  <a:cs typeface="무궁화 고딕"/>
+                  <a:sym typeface="무궁화 고딕"/>
                 </a:rPr>
                 <a:t>뒤</a:t>
               </a:r>
               <a:r>
-                <a:rPr lang="en-US" sz="4999">
+                <a:rPr lang="en-US" sz="4500">
                   <a:solidFill>
                     <a:srgbClr val="FFFAEF"/>
                   </a:solidFill>
-                  <a:latin typeface="TDTD가온"/>
-                  <a:ea typeface="TDTD가온"/>
-                  <a:cs typeface="TDTD가온"/>
-                  <a:sym typeface="TDTD가온"/>
+                  <a:latin typeface="무궁화 고딕"/>
+                  <a:ea typeface="무궁화 고딕"/>
+                  <a:cs typeface="무궁화 고딕"/>
+                  <a:sym typeface="무궁화 고딕"/>
                 </a:rPr>
                 <a:t> 두 글자를 맞추며 틀릴 때까지 계속 진행합니다.</a:t>
               </a:r>
@@ -3708,8 +3690,8 @@
           </p:nvSpPr>
           <p:spPr>
             <a:xfrm rot="0">
-              <a:off x="0" y="-171450"/>
-              <a:ext cx="7235855" cy="1237404"/>
+              <a:off x="0" y="-57150"/>
+              <a:ext cx="7481153" cy="1123104"/>
             </a:xfrm>
             <a:prstGeom prst="rect">
               <a:avLst/>
@@ -3731,10 +3713,10 @@
                   <a:solidFill>
                     <a:srgbClr val="FFFAEF"/>
                   </a:solidFill>
-                  <a:latin typeface="Jua"/>
-                  <a:ea typeface="Jua"/>
-                  <a:cs typeface="Jua"/>
-                  <a:sym typeface="Jua"/>
+                  <a:latin typeface="무궁화 고딕 Bold"/>
+                  <a:ea typeface="무궁화 고딕 Bold"/>
+                  <a:cs typeface="무궁화 고딕 Bold"/>
+                  <a:sym typeface="무궁화 고딕 Bold"/>
                 </a:rPr>
                 <a:t>STEP 2.</a:t>
               </a:r>
@@ -3782,8 +3764,8 @@
         </p:nvSpPr>
         <p:spPr>
           <a:xfrm rot="0">
-            <a:off x="3238925" y="4092795"/>
-            <a:ext cx="11810151" cy="2200275"/>
+            <a:off x="3238925" y="4378545"/>
+            <a:ext cx="11810151" cy="1914525"/>
           </a:xfrm>
           <a:prstGeom prst="rect">
             <a:avLst/>
@@ -3805,10 +3787,10 @@
                 <a:solidFill>
                   <a:srgbClr val="000000"/>
                 </a:solidFill>
-                <a:latin typeface="Jua"/>
-                <a:ea typeface="Jua"/>
-                <a:cs typeface="Jua"/>
-                <a:sym typeface="Jua"/>
+                <a:latin typeface="무궁화 고딕"/>
+                <a:ea typeface="무궁화 고딕"/>
+                <a:cs typeface="무궁화 고딕"/>
+                <a:sym typeface="무궁화 고딕"/>
               </a:rPr>
               <a:t>팀을 나눠주세요!</a:t>
             </a:r>
@@ -3955,8 +3937,8 @@
         </p:nvSpPr>
         <p:spPr>
           <a:xfrm rot="0">
-            <a:off x="1028700" y="3892867"/>
-            <a:ext cx="15555091" cy="2200275"/>
+            <a:off x="1028700" y="4178617"/>
+            <a:ext cx="15555091" cy="1914525"/>
           </a:xfrm>
           <a:prstGeom prst="rect">
             <a:avLst/>
@@ -3978,10 +3960,10 @@
                 <a:solidFill>
                   <a:srgbClr val="FFFAEF"/>
                 </a:solidFill>
-                <a:latin typeface="Jua"/>
-                <a:ea typeface="Jua"/>
-                <a:cs typeface="Jua"/>
-                <a:sym typeface="Jua"/>
+                <a:latin typeface="무궁화 고딕"/>
+                <a:ea typeface="무궁화 고딕"/>
+                <a:cs typeface="무궁화 고딕"/>
+                <a:sym typeface="무궁화 고딕"/>
               </a:rPr>
               <a:t>이어말하기</a:t>
             </a:r>
@@ -3996,8 +3978,8 @@
         </p:nvSpPr>
         <p:spPr>
           <a:xfrm rot="0">
-            <a:off x="15264803" y="9812655"/>
-            <a:ext cx="2637975" cy="474345"/>
+            <a:off x="13460066" y="9822180"/>
+            <a:ext cx="4442712" cy="464820"/>
           </a:xfrm>
           <a:prstGeom prst="rect">
             <a:avLst/>
@@ -4022,10 +4004,10 @@
                 <a:solidFill>
                   <a:srgbClr val="FFFFFF"/>
                 </a:solidFill>
-                <a:latin typeface="TDTD갬성명조"/>
-                <a:ea typeface="TDTD갬성명조"/>
-                <a:cs typeface="TDTD갬성명조"/>
-                <a:sym typeface="TDTD갬성명조"/>
+                <a:latin typeface="무궁화 고딕"/>
+                <a:ea typeface="무궁화 고딕"/>
+                <a:cs typeface="무궁화 고딕"/>
+                <a:sym typeface="무궁화 고딕"/>
               </a:rPr>
               <a:t>ⓒ 2026. Sunday Play</a:t>
             </a:r>
@@ -4097,8 +4079,8 @@
         </p:nvSpPr>
         <p:spPr>
           <a:xfrm rot="0">
-            <a:off x="4421807" y="3895725"/>
-            <a:ext cx="9444385" cy="2200275"/>
+            <a:off x="4421807" y="4181475"/>
+            <a:ext cx="9444385" cy="1914525"/>
           </a:xfrm>
           <a:prstGeom prst="rect">
             <a:avLst/>
@@ -4120,10 +4102,10 @@
                 <a:solidFill>
                   <a:srgbClr val="000000"/>
                 </a:solidFill>
-                <a:latin typeface="Jua"/>
-                <a:ea typeface="Jua"/>
-                <a:cs typeface="Jua"/>
-                <a:sym typeface="Jua"/>
+                <a:latin typeface="무궁화 고딕"/>
+                <a:ea typeface="무궁화 고딕"/>
+                <a:cs typeface="무궁화 고딕"/>
+                <a:sym typeface="무궁화 고딕"/>
               </a:rPr>
               <a:t>감사합니다!</a:t>
             </a:r>

</xml_diff>